<commit_message>
Deliverable builders take the client logo from the theme pack and the platform logo from its new folder; BRD-02 set rebuilt on the merged texts
</commit_message>
<xml_diff>
--- a/docs/deliverables/out/Drop-1_Transactional/BRD-02_Operations/01_BIBS_GuideDeck_BRD-02_Operations_v2.0.pptx
+++ b/docs/deliverables/out/Drop-1_Transactional/BRD-02_Operations/01_BIBS_GuideDeck_BRD-02_Operations_v2.0.pptx
@@ -5328,7 +5328,7 @@
       <p:grpSpPr/>
       <p:pic>
         <p:nvPicPr>
-          <p:cNvPr id="2" name="Picture 1" descr="bdo-insure.png"/>
+          <p:cNvPr id="2" name="Picture 1" descr="client-logo.png"/>
           <p:cNvPicPr>
             <a:picLocks noChangeAspect="1"/>
           </p:cNvPicPr>
@@ -5687,7 +5687,7 @@
       </p:sp>
       <p:pic>
         <p:nvPicPr>
-          <p:cNvPr id="4" name="Picture 3" descr="bdo-insure.png"/>
+          <p:cNvPr id="4" name="Picture 3" descr="client-logo.png"/>
           <p:cNvPicPr>
             <a:picLocks noChangeAspect="1"/>
           </p:cNvPicPr>
@@ -6656,7 +6656,7 @@
       </p:sp>
       <p:pic>
         <p:nvPicPr>
-          <p:cNvPr id="4" name="Picture 3" descr="bdo-insure.png"/>
+          <p:cNvPr id="4" name="Picture 3" descr="client-logo.png"/>
           <p:cNvPicPr>
             <a:picLocks noChangeAspect="1"/>
           </p:cNvPicPr>
@@ -7495,7 +7495,7 @@
       </p:sp>
       <p:pic>
         <p:nvPicPr>
-          <p:cNvPr id="4" name="Picture 3" descr="bdo-insure.png"/>
+          <p:cNvPr id="4" name="Picture 3" descr="client-logo.png"/>
           <p:cNvPicPr>
             <a:picLocks noChangeAspect="1"/>
           </p:cNvPicPr>
@@ -8088,7 +8088,7 @@
       </p:sp>
       <p:pic>
         <p:nvPicPr>
-          <p:cNvPr id="4" name="Picture 3" descr="bdo-insure.png"/>
+          <p:cNvPr id="4" name="Picture 3" descr="client-logo.png"/>
           <p:cNvPicPr>
             <a:picLocks noChangeAspect="1"/>
           </p:cNvPicPr>
@@ -8420,7 +8420,7 @@
       </p:sp>
       <p:pic>
         <p:nvPicPr>
-          <p:cNvPr id="4" name="Picture 3" descr="bdo-insure.png"/>
+          <p:cNvPr id="4" name="Picture 3" descr="client-logo.png"/>
           <p:cNvPicPr>
             <a:picLocks noChangeAspect="1"/>
           </p:cNvPicPr>
@@ -10336,7 +10336,7 @@
       </p:sp>
       <p:pic>
         <p:nvPicPr>
-          <p:cNvPr id="4" name="Picture 3" descr="bdo-insure.png"/>
+          <p:cNvPr id="4" name="Picture 3" descr="client-logo.png"/>
           <p:cNvPicPr>
             <a:picLocks noChangeAspect="1"/>
           </p:cNvPicPr>
@@ -10860,7 +10860,7 @@
       </p:sp>
       <p:pic>
         <p:nvPicPr>
-          <p:cNvPr id="4" name="Picture 3" descr="bdo-insure.png"/>
+          <p:cNvPr id="4" name="Picture 3" descr="client-logo.png"/>
           <p:cNvPicPr>
             <a:picLocks noChangeAspect="1"/>
           </p:cNvPicPr>
@@ -11273,7 +11273,7 @@
                 </a:solidFill>
                 <a:latin typeface="Arial"/>
               </a:rPr>
-              <a:t>Full list: FRS chapter 13 per screen, 148 rules on the Business rules sheet and 381 messages in FRS chapter 15 and on the Messages sheet</a:t>
+              <a:t>Full list: FRS chapter 13 per screen, 148 rules on the Business rules sheet and 382 messages in FRS chapter 15 and on the Messages sheet</a:t>
             </a:r>
           </a:p>
         </p:txBody>
@@ -11376,7 +11376,7 @@
       </p:sp>
       <p:pic>
         <p:nvPicPr>
-          <p:cNvPr id="4" name="Picture 3" descr="bdo-insure.png"/>
+          <p:cNvPr id="4" name="Picture 3" descr="client-logo.png"/>
           <p:cNvPicPr>
             <a:picLocks noChangeAspect="1"/>
           </p:cNvPicPr>
@@ -11708,7 +11708,7 @@
       </p:sp>
       <p:pic>
         <p:nvPicPr>
-          <p:cNvPr id="4" name="Picture 3" descr="bdo-insure.png"/>
+          <p:cNvPr id="4" name="Picture 3" descr="client-logo.png"/>
           <p:cNvPicPr>
             <a:picLocks noChangeAspect="1"/>
           </p:cNvPicPr>
@@ -12547,7 +12547,7 @@
       </p:sp>
       <p:pic>
         <p:nvPicPr>
-          <p:cNvPr id="4" name="Picture 3" descr="bdo-insure.png"/>
+          <p:cNvPr id="4" name="Picture 3" descr="client-logo.png"/>
           <p:cNvPicPr>
             <a:picLocks noChangeAspect="1"/>
           </p:cNvPicPr>
@@ -13209,7 +13209,7 @@
       </p:sp>
       <p:pic>
         <p:nvPicPr>
-          <p:cNvPr id="4" name="Picture 3" descr="bdo-insure.png"/>
+          <p:cNvPr id="4" name="Picture 3" descr="client-logo.png"/>
           <p:cNvPicPr>
             <a:picLocks noChangeAspect="1"/>
           </p:cNvPicPr>
@@ -13447,7 +13447,7 @@
                 </a:solidFill>
                 <a:latin typeface="Arial"/>
               </a:rPr>
-              <a:t>Content: 64 screens, 391 fields, 148 business rules, 381 messages</a:t>
+              <a:t>Content: 64 screens, 391 fields, 148 business rules, 382 messages</a:t>
             </a:r>
           </a:p>
           <a:p>
@@ -13675,7 +13675,7 @@
       </p:sp>
       <p:pic>
         <p:nvPicPr>
-          <p:cNvPr id="4" name="Picture 3" descr="bdo-insure.png"/>
+          <p:cNvPr id="4" name="Picture 3" descr="client-logo.png"/>
           <p:cNvPicPr>
             <a:picLocks noChangeAspect="1"/>
           </p:cNvPicPr>
@@ -14653,7 +14653,7 @@
       </p:sp>
       <p:pic>
         <p:nvPicPr>
-          <p:cNvPr id="4" name="Picture 3" descr="bdo-insure.png"/>
+          <p:cNvPr id="4" name="Picture 3" descr="client-logo.png"/>
           <p:cNvPicPr>
             <a:picLocks noChangeAspect="1"/>
           </p:cNvPicPr>
@@ -15094,7 +15094,7 @@
       </p:sp>
       <p:pic>
         <p:nvPicPr>
-          <p:cNvPr id="4" name="Picture 3" descr="bdo-insure.png"/>
+          <p:cNvPr id="4" name="Picture 3" descr="client-logo.png"/>
           <p:cNvPicPr>
             <a:picLocks noChangeAspect="1"/>
           </p:cNvPicPr>
@@ -15535,7 +15535,7 @@
       </p:sp>
       <p:pic>
         <p:nvPicPr>
-          <p:cNvPr id="4" name="Picture 3" descr="bdo-insure.png"/>
+          <p:cNvPr id="4" name="Picture 3" descr="client-logo.png"/>
           <p:cNvPicPr>
             <a:picLocks noChangeAspect="1"/>
           </p:cNvPicPr>
@@ -16306,7 +16306,7 @@
       </p:sp>
       <p:pic>
         <p:nvPicPr>
-          <p:cNvPr id="4" name="Picture 3" descr="bdo-insure.png"/>
+          <p:cNvPr id="4" name="Picture 3" descr="client-logo.png"/>
           <p:cNvPicPr>
             <a:picLocks noChangeAspect="1"/>
           </p:cNvPicPr>
@@ -16672,7 +16672,7 @@
       </p:sp>
       <p:pic>
         <p:nvPicPr>
-          <p:cNvPr id="4" name="Picture 3" descr="bdo-insure.png"/>
+          <p:cNvPr id="4" name="Picture 3" descr="client-logo.png"/>
           <p:cNvPicPr>
             <a:picLocks noChangeAspect="1"/>
           </p:cNvPicPr>
@@ -17508,7 +17508,7 @@
       </p:sp>
       <p:pic>
         <p:nvPicPr>
-          <p:cNvPr id="4" name="Picture 3" descr="bdo-insure.png"/>
+          <p:cNvPr id="4" name="Picture 3" descr="client-logo.png"/>
           <p:cNvPicPr>
             <a:picLocks noChangeAspect="1"/>
           </p:cNvPicPr>
@@ -18254,7 +18254,7 @@
       </p:sp>
       <p:pic>
         <p:nvPicPr>
-          <p:cNvPr id="4" name="Picture 3" descr="bdo-insure.png"/>
+          <p:cNvPr id="4" name="Picture 3" descr="client-logo.png"/>
           <p:cNvPicPr>
             <a:picLocks noChangeAspect="1"/>
           </p:cNvPicPr>
@@ -19054,7 +19054,7 @@
       </p:sp>
       <p:pic>
         <p:nvPicPr>
-          <p:cNvPr id="4" name="Picture 3" descr="bdo-insure.png"/>
+          <p:cNvPr id="4" name="Picture 3" descr="client-logo.png"/>
           <p:cNvPicPr>
             <a:picLocks noChangeAspect="1"/>
           </p:cNvPicPr>
@@ -21180,7 +21180,7 @@
       </p:sp>
       <p:pic>
         <p:nvPicPr>
-          <p:cNvPr id="4" name="Picture 3" descr="bdo-insure.png"/>
+          <p:cNvPr id="4" name="Picture 3" descr="client-logo.png"/>
           <p:cNvPicPr>
             <a:picLocks noChangeAspect="1"/>
           </p:cNvPicPr>
@@ -22037,7 +22037,7 @@
       </p:sp>
       <p:pic>
         <p:nvPicPr>
-          <p:cNvPr id="4" name="Picture 3" descr="bdo-insure.png"/>
+          <p:cNvPr id="4" name="Picture 3" descr="client-logo.png"/>
           <p:cNvPicPr>
             <a:picLocks noChangeAspect="1"/>
           </p:cNvPicPr>
@@ -22894,7 +22894,7 @@
       </p:sp>
       <p:pic>
         <p:nvPicPr>
-          <p:cNvPr id="4" name="Picture 3" descr="bdo-insure.png"/>
+          <p:cNvPr id="4" name="Picture 3" descr="client-logo.png"/>
           <p:cNvPicPr>
             <a:picLocks noChangeAspect="1"/>
           </p:cNvPicPr>

</xml_diff>

<commit_message>
BRD-02 Operations screenshots retaken in the BDO style-guide presentation on a fresh seed stack: 189 images; FRS, guide deck, sign-off workbook and UX documents 07 to 09 rebuilt at v2.0; capture takes the lists wider than their card in a wider window and opens row menus from the middle of the window
</commit_message>
<xml_diff>
--- a/docs/deliverables/out/Drop-1_Transactional/BRD-02_Operations/01_BIBS_GuideDeck_BRD-02_Operations_v2.0.pptx
+++ b/docs/deliverables/out/Drop-1_Transactional/BRD-02_Operations/01_BIBS_GuideDeck_BRD-02_Operations_v2.0.pptx
@@ -10522,8 +10522,8 @@
         </p:blipFill>
         <p:spPr>
           <a:xfrm>
-            <a:off x="1624846" y="1325880"/>
-            <a:ext cx="3257634" cy="1874520"/>
+            <a:off x="1449834" y="1325880"/>
+            <a:ext cx="3607658" cy="1874520"/>
           </a:xfrm>
           <a:prstGeom prst="rect">
             <a:avLst/>
@@ -10586,8 +10586,8 @@
         </p:blipFill>
         <p:spPr>
           <a:xfrm>
-            <a:off x="7615905" y="1325880"/>
-            <a:ext cx="2644250" cy="1874520"/>
+            <a:off x="7146345" y="1325880"/>
+            <a:ext cx="3583370" cy="1874519"/>
           </a:xfrm>
           <a:prstGeom prst="rect">
             <a:avLst/>
@@ -10714,8 +10714,8 @@
         </p:blipFill>
         <p:spPr>
           <a:xfrm>
-            <a:off x="7626332" y="3566160"/>
-            <a:ext cx="2623397" cy="1874520"/>
+            <a:off x="8084049" y="3566160"/>
+            <a:ext cx="1707963" cy="1874520"/>
           </a:xfrm>
           <a:prstGeom prst="rect">
             <a:avLst/>

</xml_diff>